<commit_message>
update to Relatório Final
</commit_message>
<xml_diff>
--- a/Docs/Arquitetura_Sistema_de_Informação.pptx
+++ b/Docs/Arquitetura_Sistema_de_Informação.pptx
@@ -136,7 +136,7 @@
       </p:grpSpPr>
       <p:sp>
         <p:nvSpPr>
-          <p:cNvPr id="992938813" name="Espaço reservado para o cabeçalho 1"/>
+          <p:cNvPr id="1211911465" name="Espaço reservado para o cabeçalho 1"/>
           <p:cNvSpPr>
             <a:spLocks noGrp="1"/>
           </p:cNvSpPr>
@@ -170,7 +170,7 @@
       </p:sp>
       <p:sp>
         <p:nvSpPr>
-          <p:cNvPr id="1508524677" name="Espaço reservado para a data 2"/>
+          <p:cNvPr id="892290249" name="Espaço reservado para a data 2"/>
           <p:cNvSpPr>
             <a:spLocks noGrp="1"/>
           </p:cNvSpPr>
@@ -208,7 +208,7 @@
       </p:sp>
       <p:sp>
         <p:nvSpPr>
-          <p:cNvPr id="581705310" name="Espaço reservado para imagem de diapositivo 3"/>
+          <p:cNvPr id="767583668" name="Espaço reservado para imagem de diapositivo 3"/>
           <p:cNvSpPr>
             <a:spLocks noChangeAspect="1" noGrp="1" noRot="1"/>
           </p:cNvSpPr>
@@ -244,7 +244,7 @@
       </p:sp>
       <p:sp>
         <p:nvSpPr>
-          <p:cNvPr id="1817709543" name="Espaço reservado às notas 4"/>
+          <p:cNvPr id="262269310" name="Espaço reservado às notas 4"/>
           <p:cNvSpPr>
             <a:spLocks noGrp="1"/>
           </p:cNvSpPr>
@@ -318,7 +318,7 @@
       </p:sp>
       <p:sp>
         <p:nvSpPr>
-          <p:cNvPr id="1909338608" name="Espaço reservado ao rodapé 5"/>
+          <p:cNvPr id="576175711" name="Espaço reservado ao rodapé 5"/>
           <p:cNvSpPr>
             <a:spLocks noGrp="1"/>
           </p:cNvSpPr>
@@ -352,7 +352,7 @@
       </p:sp>
       <p:sp>
         <p:nvSpPr>
-          <p:cNvPr id="1710234682" name="Espaço reservado para o número do diapositivo 6"/>
+          <p:cNvPr id="550297106" name="Espaço reservado para o número do diapositivo 6"/>
           <p:cNvSpPr>
             <a:spLocks noGrp="1"/>
           </p:cNvSpPr>
@@ -505,7 +505,7 @@
       </p:grpSpPr>
       <p:sp>
         <p:nvSpPr>
-          <p:cNvPr id="262020982" name="Espaço reservado para imagem de diapositivo 1"/>
+          <p:cNvPr id="1087316111" name="Espaço reservado para imagem de diapositivo 1"/>
           <p:cNvSpPr>
             <a:spLocks noChangeAspect="1" noGrp="1" noRot="1"/>
           </p:cNvSpPr>
@@ -522,7 +522,7 @@
       </p:sp>
       <p:sp>
         <p:nvSpPr>
-          <p:cNvPr id="1859777326" name="Notes Placeholder 2"/>
+          <p:cNvPr id="1351789345" name="Notes Placeholder 2"/>
           <p:cNvSpPr>
             <a:spLocks noGrp="1"/>
           </p:cNvSpPr>
@@ -547,7 +547,7 @@
       </p:sp>
       <p:sp>
         <p:nvSpPr>
-          <p:cNvPr id="759908297" name="Slide Number Placeholder 3"/>
+          <p:cNvPr id="1977577969" name="Slide Number Placeholder 3"/>
           <p:cNvSpPr>
             <a:spLocks noGrp="1"/>
           </p:cNvSpPr>
@@ -595,7 +595,7 @@
       </p:grpSpPr>
       <p:sp>
         <p:nvSpPr>
-          <p:cNvPr id="626238154" name="Espaço reservado para imagem de diapositivo 1"/>
+          <p:cNvPr id="907037418" name="Espaço reservado para imagem de diapositivo 1"/>
           <p:cNvSpPr>
             <a:spLocks noChangeAspect="1" noGrp="1" noRot="1"/>
           </p:cNvSpPr>
@@ -612,7 +612,7 @@
       </p:sp>
       <p:sp>
         <p:nvSpPr>
-          <p:cNvPr id="310065276" name="Notes Placeholder 2"/>
+          <p:cNvPr id="2110637024" name="Notes Placeholder 2"/>
           <p:cNvSpPr>
             <a:spLocks noGrp="1"/>
           </p:cNvSpPr>
@@ -637,7 +637,7 @@
       </p:sp>
       <p:sp>
         <p:nvSpPr>
-          <p:cNvPr id="1122026438" name="Slide Number Placeholder 3"/>
+          <p:cNvPr id="726297929" name="Slide Number Placeholder 3"/>
           <p:cNvSpPr>
             <a:spLocks noGrp="1"/>
           </p:cNvSpPr>
@@ -685,7 +685,7 @@
       </p:grpSpPr>
       <p:sp>
         <p:nvSpPr>
-          <p:cNvPr id="700320508" name="Espaço reservado para imagem de diapositivo 1"/>
+          <p:cNvPr id="487269984" name="Espaço reservado para imagem de diapositivo 1"/>
           <p:cNvSpPr>
             <a:spLocks noChangeAspect="1" noGrp="1" noRot="1"/>
           </p:cNvSpPr>
@@ -702,7 +702,7 @@
       </p:sp>
       <p:sp>
         <p:nvSpPr>
-          <p:cNvPr id="817565322" name="Notes Placeholder 2"/>
+          <p:cNvPr id="86307846" name="Notes Placeholder 2"/>
           <p:cNvSpPr>
             <a:spLocks noGrp="1"/>
           </p:cNvSpPr>
@@ -727,7 +727,7 @@
       </p:sp>
       <p:sp>
         <p:nvSpPr>
-          <p:cNvPr id="1926539592" name="Slide Number Placeholder 3"/>
+          <p:cNvPr id="1181810494" name="Slide Number Placeholder 3"/>
           <p:cNvSpPr>
             <a:spLocks noGrp="1"/>
           </p:cNvSpPr>
@@ -775,7 +775,7 @@
       </p:grpSpPr>
       <p:sp>
         <p:nvSpPr>
-          <p:cNvPr id="1318508607" name="Título 1"/>
+          <p:cNvPr id="254982651" name="Título 1"/>
           <p:cNvSpPr>
             <a:spLocks noGrp="1"/>
           </p:cNvSpPr>
@@ -810,7 +810,7 @@
       </p:sp>
       <p:sp>
         <p:nvSpPr>
-          <p:cNvPr id="1036022371" name="Subtítulo 2"/>
+          <p:cNvPr id="1596380369" name="Subtítulo 2"/>
           <p:cNvSpPr>
             <a:spLocks noGrp="1"/>
           </p:cNvSpPr>
@@ -878,7 +878,7 @@
       </p:sp>
       <p:sp>
         <p:nvSpPr>
-          <p:cNvPr id="1708437843" name="Date Placeholder 3"/>
+          <p:cNvPr id="111297089" name="Date Placeholder 3"/>
           <p:cNvSpPr>
             <a:spLocks noGrp="1"/>
           </p:cNvSpPr>
@@ -904,7 +904,7 @@
       </p:sp>
       <p:sp>
         <p:nvSpPr>
-          <p:cNvPr id="1046997857" name="Marcador de Posição do Rodapé 4"/>
+          <p:cNvPr id="430408456" name="Marcador de Posição do Rodapé 4"/>
           <p:cNvSpPr>
             <a:spLocks noGrp="1"/>
           </p:cNvSpPr>
@@ -926,7 +926,7 @@
       </p:sp>
       <p:sp>
         <p:nvSpPr>
-          <p:cNvPr id="464676386" name="Marcador de Posição do Número do Diapositivo 5"/>
+          <p:cNvPr id="1202107593" name="Marcador de Posição do Número do Diapositivo 5"/>
           <p:cNvSpPr>
             <a:spLocks noGrp="1"/>
           </p:cNvSpPr>
@@ -977,7 +977,7 @@
       </p:grpSpPr>
       <p:sp>
         <p:nvSpPr>
-          <p:cNvPr id="702358502" name="Title 1"/>
+          <p:cNvPr id="552956500" name="Title 1"/>
           <p:cNvSpPr>
             <a:spLocks noGrp="1"/>
           </p:cNvSpPr>
@@ -1003,7 +1003,7 @@
       </p:sp>
       <p:sp>
         <p:nvSpPr>
-          <p:cNvPr id="1694531487" name="Marcador de Posição de Texto Vertical 2"/>
+          <p:cNvPr id="339173399" name="Marcador de Posição de Texto Vertical 2"/>
           <p:cNvSpPr>
             <a:spLocks noGrp="1"/>
           </p:cNvSpPr>
@@ -1069,7 +1069,7 @@
       </p:sp>
       <p:sp>
         <p:nvSpPr>
-          <p:cNvPr id="1980446198" name="Marcador de Posição da Data 3"/>
+          <p:cNvPr id="1831287457" name="Marcador de Posição da Data 3"/>
           <p:cNvSpPr>
             <a:spLocks noGrp="1"/>
           </p:cNvSpPr>
@@ -1095,7 +1095,7 @@
       </p:sp>
       <p:sp>
         <p:nvSpPr>
-          <p:cNvPr id="731923610" name="Marcador de Posição do Rodapé 4"/>
+          <p:cNvPr id="1588063496" name="Marcador de Posição do Rodapé 4"/>
           <p:cNvSpPr>
             <a:spLocks noGrp="1"/>
           </p:cNvSpPr>
@@ -1117,7 +1117,7 @@
       </p:sp>
       <p:sp>
         <p:nvSpPr>
-          <p:cNvPr id="1296002964" name="Marcador de Posição do Número do Diapositivo 5"/>
+          <p:cNvPr id="529766085" name="Marcador de Posição do Número do Diapositivo 5"/>
           <p:cNvSpPr>
             <a:spLocks noGrp="1"/>
           </p:cNvSpPr>
@@ -1168,7 +1168,7 @@
       </p:grpSpPr>
       <p:sp>
         <p:nvSpPr>
-          <p:cNvPr id="117379617" name="Título Vertical 1"/>
+          <p:cNvPr id="845265465" name="Título Vertical 1"/>
           <p:cNvSpPr>
             <a:spLocks noGrp="1"/>
           </p:cNvSpPr>
@@ -1199,7 +1199,7 @@
       </p:sp>
       <p:sp>
         <p:nvSpPr>
-          <p:cNvPr id="1580394219" name="Marcador de Posição de Texto Vertical 2"/>
+          <p:cNvPr id="2018246228" name="Marcador de Posição de Texto Vertical 2"/>
           <p:cNvSpPr>
             <a:spLocks noGrp="1"/>
           </p:cNvSpPr>
@@ -1270,7 +1270,7 @@
       </p:sp>
       <p:sp>
         <p:nvSpPr>
-          <p:cNvPr id="316293117" name="Marcador de Posição da Data 3"/>
+          <p:cNvPr id="1659789176" name="Marcador de Posição da Data 3"/>
           <p:cNvSpPr>
             <a:spLocks noGrp="1"/>
           </p:cNvSpPr>
@@ -1296,7 +1296,7 @@
       </p:sp>
       <p:sp>
         <p:nvSpPr>
-          <p:cNvPr id="1138077347" name="Marcador de Posição do Rodapé 4"/>
+          <p:cNvPr id="1405939389" name="Marcador de Posição do Rodapé 4"/>
           <p:cNvSpPr>
             <a:spLocks noGrp="1"/>
           </p:cNvSpPr>
@@ -1318,7 +1318,7 @@
       </p:sp>
       <p:sp>
         <p:nvSpPr>
-          <p:cNvPr id="276696217" name="Marcador de Posição do Número do Diapositivo 5"/>
+          <p:cNvPr id="674656808" name="Marcador de Posição do Número do Diapositivo 5"/>
           <p:cNvSpPr>
             <a:spLocks noGrp="1"/>
           </p:cNvSpPr>
@@ -1369,7 +1369,7 @@
       </p:grpSpPr>
       <p:sp>
         <p:nvSpPr>
-          <p:cNvPr id="428940218" name="Título 1"/>
+          <p:cNvPr id="1667522556" name="Título 1"/>
           <p:cNvSpPr>
             <a:spLocks noGrp="1"/>
           </p:cNvSpPr>
@@ -1395,7 +1395,7 @@
       </p:sp>
       <p:sp>
         <p:nvSpPr>
-          <p:cNvPr id="966745362" name="Marcador de Posição de Conteúdo 2"/>
+          <p:cNvPr id="717766693" name="Marcador de Posição de Conteúdo 2"/>
           <p:cNvSpPr>
             <a:spLocks noGrp="1"/>
           </p:cNvSpPr>
@@ -1461,7 +1461,7 @@
       </p:sp>
       <p:sp>
         <p:nvSpPr>
-          <p:cNvPr id="1954701443" name="Marcador de Posição da Data 3"/>
+          <p:cNvPr id="420575171" name="Marcador de Posição da Data 3"/>
           <p:cNvSpPr>
             <a:spLocks noGrp="1"/>
           </p:cNvSpPr>
@@ -1487,7 +1487,7 @@
       </p:sp>
       <p:sp>
         <p:nvSpPr>
-          <p:cNvPr id="1993675089" name="Marcador de Posição do Rodapé 4"/>
+          <p:cNvPr id="1866536438" name="Marcador de Posição do Rodapé 4"/>
           <p:cNvSpPr>
             <a:spLocks noGrp="1"/>
           </p:cNvSpPr>
@@ -1509,7 +1509,7 @@
       </p:sp>
       <p:sp>
         <p:nvSpPr>
-          <p:cNvPr id="1147508462" name="Marcador de Posição do Número do Diapositivo 5"/>
+          <p:cNvPr id="995276189" name="Marcador de Posição do Número do Diapositivo 5"/>
           <p:cNvSpPr>
             <a:spLocks noGrp="1"/>
           </p:cNvSpPr>
@@ -1560,7 +1560,7 @@
       </p:grpSpPr>
       <p:sp>
         <p:nvSpPr>
-          <p:cNvPr id="704084027" name="Título 1"/>
+          <p:cNvPr id="1003595125" name="Título 1"/>
           <p:cNvSpPr>
             <a:spLocks noGrp="1"/>
           </p:cNvSpPr>
@@ -1595,7 +1595,7 @@
       </p:sp>
       <p:sp>
         <p:nvSpPr>
-          <p:cNvPr id="618085553" name="Marcador de Posição do Texto 2"/>
+          <p:cNvPr id="1643277404" name="Marcador de Posição do Texto 2"/>
           <p:cNvSpPr>
             <a:spLocks noGrp="1"/>
           </p:cNvSpPr>
@@ -1717,7 +1717,7 @@
       </p:sp>
       <p:sp>
         <p:nvSpPr>
-          <p:cNvPr id="453968348" name="Marcador de Posição da Data 3"/>
+          <p:cNvPr id="991470878" name="Marcador de Posição da Data 3"/>
           <p:cNvSpPr>
             <a:spLocks noGrp="1"/>
           </p:cNvSpPr>
@@ -1743,7 +1743,7 @@
       </p:sp>
       <p:sp>
         <p:nvSpPr>
-          <p:cNvPr id="1306132319" name="Marcador de Posição do Rodapé 4"/>
+          <p:cNvPr id="912248683" name="Marcador de Posição do Rodapé 4"/>
           <p:cNvSpPr>
             <a:spLocks noGrp="1"/>
           </p:cNvSpPr>
@@ -1765,7 +1765,7 @@
       </p:sp>
       <p:sp>
         <p:nvSpPr>
-          <p:cNvPr id="681353583" name="Marcador de Posição do Número do Diapositivo 5"/>
+          <p:cNvPr id="520222412" name="Marcador de Posição do Número do Diapositivo 5"/>
           <p:cNvSpPr>
             <a:spLocks noGrp="1"/>
           </p:cNvSpPr>
@@ -1816,7 +1816,7 @@
       </p:grpSpPr>
       <p:sp>
         <p:nvSpPr>
-          <p:cNvPr id="579769645" name="Título 1"/>
+          <p:cNvPr id="1486729912" name="Título 1"/>
           <p:cNvSpPr>
             <a:spLocks noGrp="1"/>
           </p:cNvSpPr>
@@ -1842,7 +1842,7 @@
       </p:sp>
       <p:sp>
         <p:nvSpPr>
-          <p:cNvPr id="2023688444" name="Marcador de Posição de Conteúdo 2"/>
+          <p:cNvPr id="559434509" name="Marcador de Posição de Conteúdo 2"/>
           <p:cNvSpPr>
             <a:spLocks noGrp="1"/>
           </p:cNvSpPr>
@@ -1913,7 +1913,7 @@
       </p:sp>
       <p:sp>
         <p:nvSpPr>
-          <p:cNvPr id="661555888" name="Marcador de Posição de Conteúdo 3"/>
+          <p:cNvPr id="1895236510" name="Marcador de Posição de Conteúdo 3"/>
           <p:cNvSpPr>
             <a:spLocks noGrp="1"/>
           </p:cNvSpPr>
@@ -1984,7 +1984,7 @@
       </p:sp>
       <p:sp>
         <p:nvSpPr>
-          <p:cNvPr id="1125834775" name="Marcador de Posição da Data 4"/>
+          <p:cNvPr id="426115230" name="Marcador de Posição da Data 4"/>
           <p:cNvSpPr>
             <a:spLocks noGrp="1"/>
           </p:cNvSpPr>
@@ -2010,7 +2010,7 @@
       </p:sp>
       <p:sp>
         <p:nvSpPr>
-          <p:cNvPr id="1330002229" name="Marcador de Posição do Rodapé 5"/>
+          <p:cNvPr id="1883249515" name="Marcador de Posição do Rodapé 5"/>
           <p:cNvSpPr>
             <a:spLocks noGrp="1"/>
           </p:cNvSpPr>
@@ -2032,7 +2032,7 @@
       </p:sp>
       <p:sp>
         <p:nvSpPr>
-          <p:cNvPr id="77984530" name="Marcador de Posição do Número do Diapositivo 6"/>
+          <p:cNvPr id="1170977029" name="Marcador de Posição do Número do Diapositivo 6"/>
           <p:cNvSpPr>
             <a:spLocks noGrp="1"/>
           </p:cNvSpPr>
@@ -2083,7 +2083,7 @@
       </p:grpSpPr>
       <p:sp>
         <p:nvSpPr>
-          <p:cNvPr id="2012877127" name="Título 1"/>
+          <p:cNvPr id="1432712405" name="Título 1"/>
           <p:cNvSpPr>
             <a:spLocks noGrp="1"/>
           </p:cNvSpPr>
@@ -2114,7 +2114,7 @@
       </p:sp>
       <p:sp>
         <p:nvSpPr>
-          <p:cNvPr id="582845715" name="Marcador de Posição do Texto 2"/>
+          <p:cNvPr id="685922901" name="Marcador de Posição do Texto 2"/>
           <p:cNvSpPr>
             <a:spLocks noGrp="1"/>
           </p:cNvSpPr>
@@ -2182,7 +2182,7 @@
       </p:sp>
       <p:sp>
         <p:nvSpPr>
-          <p:cNvPr id="1884899871" name="Marcador de Posição de Conteúdo 3"/>
+          <p:cNvPr id="1640860054" name="Marcador de Posição de Conteúdo 3"/>
           <p:cNvSpPr>
             <a:spLocks noGrp="1"/>
           </p:cNvSpPr>
@@ -2253,7 +2253,7 @@
       </p:sp>
       <p:sp>
         <p:nvSpPr>
-          <p:cNvPr id="1641247426" name="Marcador de Posição do Texto 4"/>
+          <p:cNvPr id="1223064838" name="Marcador de Posição do Texto 4"/>
           <p:cNvSpPr>
             <a:spLocks noGrp="1"/>
           </p:cNvSpPr>
@@ -2321,7 +2321,7 @@
       </p:sp>
       <p:sp>
         <p:nvSpPr>
-          <p:cNvPr id="551713026" name="Marcador de Posição de Conteúdo 5"/>
+          <p:cNvPr id="1041218332" name="Marcador de Posição de Conteúdo 5"/>
           <p:cNvSpPr>
             <a:spLocks noGrp="1"/>
           </p:cNvSpPr>
@@ -2392,7 +2392,7 @@
       </p:sp>
       <p:sp>
         <p:nvSpPr>
-          <p:cNvPr id="1163409132" name="Marcador de Posição da Data 6"/>
+          <p:cNvPr id="149835231" name="Marcador de Posição da Data 6"/>
           <p:cNvSpPr>
             <a:spLocks noGrp="1"/>
           </p:cNvSpPr>
@@ -2418,7 +2418,7 @@
       </p:sp>
       <p:sp>
         <p:nvSpPr>
-          <p:cNvPr id="1677451662" name="Marcador de Posição do Rodapé 7"/>
+          <p:cNvPr id="1888700811" name="Marcador de Posição do Rodapé 7"/>
           <p:cNvSpPr>
             <a:spLocks noGrp="1"/>
           </p:cNvSpPr>
@@ -2440,7 +2440,7 @@
       </p:sp>
       <p:sp>
         <p:nvSpPr>
-          <p:cNvPr id="971455561" name="Marcador de Posição do Número do Diapositivo 8"/>
+          <p:cNvPr id="1617256357" name="Marcador de Posição do Número do Diapositivo 8"/>
           <p:cNvSpPr>
             <a:spLocks noGrp="1"/>
           </p:cNvSpPr>
@@ -2491,7 +2491,7 @@
       </p:grpSpPr>
       <p:sp>
         <p:nvSpPr>
-          <p:cNvPr id="1452998240" name="Título 1"/>
+          <p:cNvPr id="534677710" name="Título 1"/>
           <p:cNvSpPr>
             <a:spLocks noGrp="1"/>
           </p:cNvSpPr>
@@ -2517,7 +2517,7 @@
       </p:sp>
       <p:sp>
         <p:nvSpPr>
-          <p:cNvPr id="1892951998" name="Marcador de Posição da Data 2"/>
+          <p:cNvPr id="1155937034" name="Marcador de Posição da Data 2"/>
           <p:cNvSpPr>
             <a:spLocks noGrp="1"/>
           </p:cNvSpPr>
@@ -2543,7 +2543,7 @@
       </p:sp>
       <p:sp>
         <p:nvSpPr>
-          <p:cNvPr id="756234275" name="Marcador de Posição do Rodapé 3"/>
+          <p:cNvPr id="1796844341" name="Marcador de Posição do Rodapé 3"/>
           <p:cNvSpPr>
             <a:spLocks noGrp="1"/>
           </p:cNvSpPr>
@@ -2565,7 +2565,7 @@
       </p:sp>
       <p:sp>
         <p:nvSpPr>
-          <p:cNvPr id="700085600" name="Marcador de Posição do Número do Diapositivo 4"/>
+          <p:cNvPr id="757217529" name="Marcador de Posição do Número do Diapositivo 4"/>
           <p:cNvSpPr>
             <a:spLocks noGrp="1"/>
           </p:cNvSpPr>
@@ -2616,7 +2616,7 @@
       </p:grpSpPr>
       <p:sp>
         <p:nvSpPr>
-          <p:cNvPr id="1964470180" name="Marcador de Posição da Data 1"/>
+          <p:cNvPr id="1850576944" name="Marcador de Posição da Data 1"/>
           <p:cNvSpPr>
             <a:spLocks noGrp="1"/>
           </p:cNvSpPr>
@@ -2642,7 +2642,7 @@
       </p:sp>
       <p:sp>
         <p:nvSpPr>
-          <p:cNvPr id="2065683802" name="Marcador de Posição do Rodapé 2"/>
+          <p:cNvPr id="1902287952" name="Marcador de Posição do Rodapé 2"/>
           <p:cNvSpPr>
             <a:spLocks noGrp="1"/>
           </p:cNvSpPr>
@@ -2664,7 +2664,7 @@
       </p:sp>
       <p:sp>
         <p:nvSpPr>
-          <p:cNvPr id="1982296436" name="Marcador de Posição do Número do Diapositivo 3"/>
+          <p:cNvPr id="1434124993" name="Marcador de Posição do Número do Diapositivo 3"/>
           <p:cNvSpPr>
             <a:spLocks noGrp="1"/>
           </p:cNvSpPr>
@@ -2715,7 +2715,7 @@
       </p:grpSpPr>
       <p:sp>
         <p:nvSpPr>
-          <p:cNvPr id="999306232" name="Título 1"/>
+          <p:cNvPr id="2025222524" name="Título 1"/>
           <p:cNvSpPr>
             <a:spLocks noGrp="1"/>
           </p:cNvSpPr>
@@ -2750,7 +2750,7 @@
       </p:sp>
       <p:sp>
         <p:nvSpPr>
-          <p:cNvPr id="1803469469" name="Marcador de Posição de Conteúdo 2"/>
+          <p:cNvPr id="45891289" name="Marcador de Posição de Conteúdo 2"/>
           <p:cNvSpPr>
             <a:spLocks noGrp="1"/>
           </p:cNvSpPr>
@@ -2849,7 +2849,7 @@
       </p:sp>
       <p:sp>
         <p:nvSpPr>
-          <p:cNvPr id="255079220" name="Marcador de Posição do Texto 3"/>
+          <p:cNvPr id="210844008" name="Marcador de Posição do Texto 3"/>
           <p:cNvSpPr>
             <a:spLocks noGrp="1"/>
           </p:cNvSpPr>
@@ -2917,7 +2917,7 @@
       </p:sp>
       <p:sp>
         <p:nvSpPr>
-          <p:cNvPr id="1879363129" name="Marcador de Posição da Data 4"/>
+          <p:cNvPr id="1384382204" name="Marcador de Posição da Data 4"/>
           <p:cNvSpPr>
             <a:spLocks noGrp="1"/>
           </p:cNvSpPr>
@@ -2943,7 +2943,7 @@
       </p:sp>
       <p:sp>
         <p:nvSpPr>
-          <p:cNvPr id="422531004" name="Footer Placeholder 5"/>
+          <p:cNvPr id="806793518" name="Footer Placeholder 5"/>
           <p:cNvSpPr>
             <a:spLocks noGrp="1"/>
           </p:cNvSpPr>
@@ -2965,7 +2965,7 @@
       </p:sp>
       <p:sp>
         <p:nvSpPr>
-          <p:cNvPr id="1946227716" name="Marcador de Posição do Número do Diapositivo 6"/>
+          <p:cNvPr id="1269236881" name="Marcador de Posição do Número do Diapositivo 6"/>
           <p:cNvSpPr>
             <a:spLocks noGrp="1"/>
           </p:cNvSpPr>
@@ -3016,7 +3016,7 @@
       </p:grpSpPr>
       <p:sp>
         <p:nvSpPr>
-          <p:cNvPr id="1684961262" name="Título 1"/>
+          <p:cNvPr id="1514788107" name="Título 1"/>
           <p:cNvSpPr>
             <a:spLocks noGrp="1"/>
           </p:cNvSpPr>
@@ -3051,7 +3051,7 @@
       </p:sp>
       <p:sp>
         <p:nvSpPr>
-          <p:cNvPr id="450554310" name="Marcador de Posição da Imagem 2"/>
+          <p:cNvPr id="507122279" name="Marcador de Posição da Imagem 2"/>
           <p:cNvSpPr>
             <a:spLocks noChangeAspect="1" noGrp="1"/>
           </p:cNvSpPr>
@@ -3119,7 +3119,7 @@
       </p:sp>
       <p:sp>
         <p:nvSpPr>
-          <p:cNvPr id="681416228" name="Marcador de Posição do Texto 3"/>
+          <p:cNvPr id="1576937324" name="Marcador de Posição do Texto 3"/>
           <p:cNvSpPr>
             <a:spLocks noGrp="1"/>
           </p:cNvSpPr>
@@ -3187,7 +3187,7 @@
       </p:sp>
       <p:sp>
         <p:nvSpPr>
-          <p:cNvPr id="118838677" name="Marcador de Posição da Data 4"/>
+          <p:cNvPr id="884309511" name="Marcador de Posição da Data 4"/>
           <p:cNvSpPr>
             <a:spLocks noGrp="1"/>
           </p:cNvSpPr>
@@ -3213,7 +3213,7 @@
       </p:sp>
       <p:sp>
         <p:nvSpPr>
-          <p:cNvPr id="465490913" name="Marcador de Posição do Rodapé 5"/>
+          <p:cNvPr id="1635569448" name="Marcador de Posição do Rodapé 5"/>
           <p:cNvSpPr>
             <a:spLocks noGrp="1"/>
           </p:cNvSpPr>
@@ -3235,7 +3235,7 @@
       </p:sp>
       <p:sp>
         <p:nvSpPr>
-          <p:cNvPr id="1434943905" name="Marcador de Posição do Número do Diapositivo 6"/>
+          <p:cNvPr id="314642721" name="Marcador de Posição do Número do Diapositivo 6"/>
           <p:cNvSpPr>
             <a:spLocks noGrp="1"/>
           </p:cNvSpPr>
@@ -3291,7 +3291,7 @@
       </p:grpSpPr>
       <p:sp>
         <p:nvSpPr>
-          <p:cNvPr id="185744363" name="Marcador de Posição do Título 1"/>
+          <p:cNvPr id="356850822" name="Marcador de Posição do Título 1"/>
           <p:cNvSpPr>
             <a:spLocks noGrp="1"/>
           </p:cNvSpPr>
@@ -3327,7 +3327,7 @@
       </p:sp>
       <p:sp>
         <p:nvSpPr>
-          <p:cNvPr id="1750930060" name="Marcador de Posição do Texto 2"/>
+          <p:cNvPr id="379877778" name="Marcador de Posição do Texto 2"/>
           <p:cNvSpPr>
             <a:spLocks noGrp="1"/>
           </p:cNvSpPr>
@@ -3403,7 +3403,7 @@
       </p:sp>
       <p:sp>
         <p:nvSpPr>
-          <p:cNvPr id="311410308" name="Marcador de Posição da Data 3"/>
+          <p:cNvPr id="2084122039" name="Marcador de Posição da Data 3"/>
           <p:cNvSpPr>
             <a:spLocks noGrp="1"/>
           </p:cNvSpPr>
@@ -3447,7 +3447,7 @@
       </p:sp>
       <p:sp>
         <p:nvSpPr>
-          <p:cNvPr id="453104110" name="Marcador de Posição do Rodapé 4"/>
+          <p:cNvPr id="1144359960" name="Marcador de Posição do Rodapé 4"/>
           <p:cNvSpPr>
             <a:spLocks noGrp="1"/>
           </p:cNvSpPr>
@@ -3487,7 +3487,7 @@
       </p:sp>
       <p:sp>
         <p:nvSpPr>
-          <p:cNvPr id="1666090886" name="Marcador de Posição do Número do Diapositivo 5"/>
+          <p:cNvPr id="1519989275" name="Marcador de Posição do Número do Diapositivo 5"/>
           <p:cNvSpPr>
             <a:spLocks noGrp="1"/>
           </p:cNvSpPr>
@@ -3847,7 +3847,7 @@
       </p:grpSpPr>
       <p:pic>
         <p:nvPicPr>
-          <p:cNvPr id="973742971" name=""/>
+          <p:cNvPr id="274140487" name=""/>
           <p:cNvPicPr>
             <a:picLocks noChangeAspect="1"/>
           </p:cNvPicPr>
@@ -3870,7 +3870,7 @@
       </p:pic>
       <p:sp>
         <p:nvSpPr>
-          <p:cNvPr id="623149419" name=""/>
+          <p:cNvPr id="295156474" name=""/>
           <p:cNvSpPr/>
           <p:nvPr/>
         </p:nvSpPr>
@@ -3919,7 +3919,7 @@
       </p:sp>
       <p:sp>
         <p:nvSpPr>
-          <p:cNvPr id="61467405" name=""/>
+          <p:cNvPr id="1028458236" name=""/>
           <p:cNvSpPr/>
           <p:nvPr/>
         </p:nvSpPr>
@@ -4028,14 +4028,14 @@
       </p:sp>
       <p:sp>
         <p:nvSpPr>
-          <p:cNvPr id="1452224757" name=""/>
+          <p:cNvPr id="1478992815" name=""/>
           <p:cNvSpPr/>
           <p:nvPr/>
         </p:nvSpPr>
         <p:spPr bwMode="auto">
           <a:xfrm flipH="0" flipV="0">
             <a:off x="5539761" y="1037428"/>
-            <a:ext cx="1632130" cy="700740"/>
+            <a:ext cx="1632129" cy="700740"/>
           </a:xfrm>
           <a:prstGeom prst="rect">
             <a:avLst/>
@@ -4123,7 +4123,7 @@
       </p:sp>
       <p:sp>
         <p:nvSpPr>
-          <p:cNvPr id="1574944202" name="Título 1"/>
+          <p:cNvPr id="1252222309" name="Título 1"/>
           <p:cNvSpPr>
             <a:spLocks noGrp="1"/>
           </p:cNvSpPr>
@@ -4251,7 +4251,7 @@
       </p:sp>
       <p:sp>
         <p:nvSpPr>
-          <p:cNvPr id="435276045" name=""/>
+          <p:cNvPr id="790040626" name=""/>
           <p:cNvSpPr/>
           <p:nvPr/>
         </p:nvSpPr>
@@ -4360,7 +4360,7 @@
       </p:sp>
       <p:sp>
         <p:nvSpPr>
-          <p:cNvPr id="713729558" name=""/>
+          <p:cNvPr id="1361057770" name=""/>
           <p:cNvSpPr/>
           <p:nvPr/>
         </p:nvSpPr>
@@ -4643,7 +4643,7 @@
                   <a:schemeClr val="tx1"/>
                 </a:solidFill>
               </a:rPr>
-              <a:t>Google / Facebook</a:t>
+              <a:t>Google</a:t>
             </a:r>
             <a:endParaRPr sz="1200">
               <a:solidFill>
@@ -4708,7 +4708,7 @@
       </p:sp>
       <p:sp>
         <p:nvSpPr>
-          <p:cNvPr id="842753003" name=""/>
+          <p:cNvPr id="565784891" name=""/>
           <p:cNvSpPr/>
           <p:nvPr/>
         </p:nvSpPr>
@@ -4803,7 +4803,7 @@
       </p:sp>
       <p:cxnSp>
         <p:nvCxnSpPr>
-          <p:cNvPr id="30598548" name=""/>
+          <p:cNvPr id="1016257661" name=""/>
           <p:cNvCxnSpPr/>
           <p:nvPr/>
         </p:nvCxnSpPr>
@@ -4847,15 +4847,15 @@
       </p:cxnSp>
       <p:cxnSp>
         <p:nvCxnSpPr>
-          <p:cNvPr id="434161189" name=""/>
+          <p:cNvPr id="909963569" name=""/>
           <p:cNvCxnSpPr>
-            <a:stCxn id="1452224757" idx="1"/>
-            <a:endCxn id="713729558" idx="0"/>
+            <a:stCxn id="1478992815" idx="1"/>
+            <a:endCxn id="1361057770" idx="0"/>
           </p:cNvCxnSpPr>
           <p:nvPr/>
         </p:nvCxnSpPr>
         <p:spPr bwMode="auto">
-          <a:xfrm rot="10799990" flipH="0" flipV="1">
+          <a:xfrm rot="10799989" flipH="0" flipV="1">
             <a:off x="4588642" y="1387798"/>
             <a:ext cx="951117" cy="454837"/>
           </a:xfrm>
@@ -4891,7 +4891,7 @@
       </p:cxnSp>
       <p:sp>
         <p:nvSpPr>
-          <p:cNvPr id="1269980424" name=""/>
+          <p:cNvPr id="1411596089" name=""/>
           <p:cNvSpPr/>
           <p:nvPr/>
         </p:nvSpPr>
@@ -5014,9 +5014,9 @@
       </p:sp>
       <p:cxnSp>
         <p:nvCxnSpPr>
-          <p:cNvPr id="929940375" name=""/>
+          <p:cNvPr id="1596161223" name=""/>
           <p:cNvCxnSpPr>
-            <a:stCxn id="1269980424" idx="1"/>
+            <a:stCxn id="1411596089" idx="1"/>
           </p:cNvCxnSpPr>
           <p:nvPr/>
         </p:nvCxnSpPr>
@@ -5060,7 +5060,7 @@
       </p:cxnSp>
       <p:sp>
         <p:nvSpPr>
-          <p:cNvPr id="101382779" name=""/>
+          <p:cNvPr id="972841704" name=""/>
           <p:cNvSpPr txBox="1"/>
           <p:nvPr/>
         </p:nvSpPr>
@@ -5092,7 +5092,7 @@
       </p:sp>
       <p:cxnSp>
         <p:nvCxnSpPr>
-          <p:cNvPr id="49320634" name=""/>
+          <p:cNvPr id="1095274410" name=""/>
           <p:cNvCxnSpPr/>
           <p:nvPr/>
         </p:nvCxnSpPr>
@@ -5136,7 +5136,7 @@
       </p:cxnSp>
       <p:sp>
         <p:nvSpPr>
-          <p:cNvPr id="1170418410" name=""/>
+          <p:cNvPr id="1845631632" name=""/>
           <p:cNvSpPr/>
           <p:nvPr/>
         </p:nvSpPr>
@@ -5303,7 +5303,7 @@
       </p:sp>
       <p:sp>
         <p:nvSpPr>
-          <p:cNvPr id="1676337407" name=""/>
+          <p:cNvPr id="1932803744" name=""/>
           <p:cNvSpPr/>
           <p:nvPr/>
         </p:nvSpPr>
@@ -5470,9 +5470,9 @@
       </p:sp>
       <p:cxnSp>
         <p:nvCxnSpPr>
-          <p:cNvPr id="176002265" name=""/>
+          <p:cNvPr id="1684417981" name=""/>
           <p:cNvCxnSpPr>
-            <a:endCxn id="1676337407" idx="1"/>
+            <a:endCxn id="1932803744" idx="1"/>
           </p:cNvCxnSpPr>
           <p:nvPr/>
         </p:nvCxnSpPr>
@@ -5513,10 +5513,10 @@
       </p:cxnSp>
       <p:cxnSp>
         <p:nvCxnSpPr>
-          <p:cNvPr id="1046957508" name=""/>
+          <p:cNvPr id="699665457" name=""/>
           <p:cNvCxnSpPr>
-            <a:stCxn id="1269980424" idx="3"/>
-            <a:endCxn id="1170418410" idx="1"/>
+            <a:stCxn id="1411596089" idx="3"/>
+            <a:endCxn id="1845631632" idx="1"/>
           </p:cNvCxnSpPr>
           <p:nvPr/>
         </p:nvCxnSpPr>
@@ -5557,9 +5557,9 @@
       </p:cxnSp>
       <p:cxnSp>
         <p:nvCxnSpPr>
-          <p:cNvPr id="988870115" name=""/>
+          <p:cNvPr id="937739192" name=""/>
           <p:cNvCxnSpPr>
-            <a:stCxn id="842753003" idx="3"/>
+            <a:stCxn id="565784891" idx="3"/>
           </p:cNvCxnSpPr>
           <p:nvPr/>
         </p:nvCxnSpPr>
@@ -5600,7 +5600,7 @@
       </p:cxnSp>
       <p:pic>
         <p:nvPicPr>
-          <p:cNvPr id="1834689802" name=""/>
+          <p:cNvPr id="982224262" name=""/>
           <p:cNvPicPr>
             <a:picLocks noChangeAspect="1"/>
           </p:cNvPicPr>
@@ -5622,7 +5622,7 @@
       </p:pic>
       <p:pic>
         <p:nvPicPr>
-          <p:cNvPr id="1978043296" name=""/>
+          <p:cNvPr id="1534357775" name=""/>
           <p:cNvPicPr>
             <a:picLocks noChangeAspect="1"/>
           </p:cNvPicPr>
@@ -5634,7 +5634,7 @@
         </p:blipFill>
         <p:spPr bwMode="auto">
           <a:xfrm flipH="0" flipV="0">
-            <a:off x="1335862" y="5115402"/>
+            <a:off x="1335861" y="5115402"/>
             <a:ext cx="1129305" cy="635234"/>
           </a:xfrm>
           <a:prstGeom prst="rect">
@@ -5644,7 +5644,7 @@
       </p:pic>
       <p:pic>
         <p:nvPicPr>
-          <p:cNvPr id="2145588639" name=""/>
+          <p:cNvPr id="1403590893" name=""/>
           <p:cNvPicPr>
             <a:picLocks noChangeAspect="1"/>
           </p:cNvPicPr>
@@ -5667,7 +5667,7 @@
       </p:pic>
       <p:pic>
         <p:nvPicPr>
-          <p:cNvPr id="935322903" name=""/>
+          <p:cNvPr id="1989508650" name=""/>
           <p:cNvPicPr>
             <a:picLocks noChangeAspect="1"/>
           </p:cNvPicPr>
@@ -5689,7 +5689,7 @@
       </p:pic>
       <p:pic>
         <p:nvPicPr>
-          <p:cNvPr id="2141126661" name=""/>
+          <p:cNvPr id="1696579643" name=""/>
           <p:cNvPicPr>
             <a:picLocks noChangeAspect="1"/>
           </p:cNvPicPr>
@@ -5712,7 +5712,7 @@
       </p:pic>
       <p:pic>
         <p:nvPicPr>
-          <p:cNvPr id="591009877" name=""/>
+          <p:cNvPr id="229853049" name=""/>
           <p:cNvPicPr>
             <a:picLocks noChangeAspect="1"/>
           </p:cNvPicPr>
@@ -5734,7 +5734,7 @@
       </p:pic>
       <p:pic>
         <p:nvPicPr>
-          <p:cNvPr id="1493429597" name=""/>
+          <p:cNvPr id="1930486080" name=""/>
           <p:cNvPicPr>
             <a:picLocks noChangeAspect="1"/>
           </p:cNvPicPr>
@@ -5756,7 +5756,7 @@
       </p:pic>
       <p:pic>
         <p:nvPicPr>
-          <p:cNvPr id="732640469" name=""/>
+          <p:cNvPr id="1779886064" name=""/>
           <p:cNvPicPr>
             <a:picLocks noChangeAspect="1"/>
           </p:cNvPicPr>
@@ -5778,7 +5778,7 @@
       </p:pic>
       <p:pic>
         <p:nvPicPr>
-          <p:cNvPr id="815009281" name=""/>
+          <p:cNvPr id="1709852583" name=""/>
           <p:cNvPicPr>
             <a:picLocks noChangeAspect="1"/>
           </p:cNvPicPr>
@@ -5800,7 +5800,7 @@
       </p:pic>
       <p:pic>
         <p:nvPicPr>
-          <p:cNvPr id="1029672738" name=""/>
+          <p:cNvPr id="1245554123" name=""/>
           <p:cNvPicPr>
             <a:picLocks noChangeAspect="1"/>
           </p:cNvPicPr>
@@ -5822,7 +5822,7 @@
       </p:pic>
       <p:pic>
         <p:nvPicPr>
-          <p:cNvPr id="852702761" name=""/>
+          <p:cNvPr id="459501123" name=""/>
           <p:cNvPicPr>
             <a:picLocks noChangeAspect="1"/>
           </p:cNvPicPr>
@@ -5877,7 +5877,7 @@
       </p:grpSpPr>
       <p:sp>
         <p:nvSpPr>
-          <p:cNvPr id="1696936982" name=""/>
+          <p:cNvPr id="1583453714" name=""/>
           <p:cNvSpPr/>
           <p:nvPr/>
         </p:nvSpPr>
@@ -5926,7 +5926,7 @@
       </p:sp>
       <p:sp>
         <p:nvSpPr>
-          <p:cNvPr id="2128656028" name=""/>
+          <p:cNvPr id="1802444365" name=""/>
           <p:cNvSpPr/>
           <p:nvPr/>
         </p:nvSpPr>
@@ -6035,7 +6035,7 @@
       </p:sp>
       <p:sp>
         <p:nvSpPr>
-          <p:cNvPr id="1931292359" name=""/>
+          <p:cNvPr id="290775617" name=""/>
           <p:cNvSpPr/>
           <p:nvPr/>
         </p:nvSpPr>
@@ -6130,7 +6130,7 @@
       </p:sp>
       <p:sp>
         <p:nvSpPr>
-          <p:cNvPr id="282720531" name="Título 1"/>
+          <p:cNvPr id="1776046695" name="Título 1"/>
           <p:cNvSpPr>
             <a:spLocks noGrp="1"/>
           </p:cNvSpPr>
@@ -6176,7 +6176,7 @@
       </p:sp>
       <p:sp>
         <p:nvSpPr>
-          <p:cNvPr id="1888988122" name=""/>
+          <p:cNvPr id="290239998" name=""/>
           <p:cNvSpPr/>
           <p:nvPr/>
         </p:nvSpPr>
@@ -6285,7 +6285,7 @@
       </p:sp>
       <p:sp>
         <p:nvSpPr>
-          <p:cNvPr id="2021581954" name=""/>
+          <p:cNvPr id="610845665" name=""/>
           <p:cNvSpPr/>
           <p:nvPr/>
         </p:nvSpPr>
@@ -6592,7 +6592,7 @@
       </p:sp>
       <p:sp>
         <p:nvSpPr>
-          <p:cNvPr id="1084796001" name=""/>
+          <p:cNvPr id="1069639831" name=""/>
           <p:cNvSpPr/>
           <p:nvPr/>
         </p:nvSpPr>
@@ -6687,7 +6687,7 @@
       </p:sp>
       <p:sp>
         <p:nvSpPr>
-          <p:cNvPr id="159929188" name=""/>
+          <p:cNvPr id="635296686" name=""/>
           <p:cNvSpPr/>
           <p:nvPr/>
         </p:nvSpPr>
@@ -6842,10 +6842,10 @@
       </p:sp>
       <p:cxnSp>
         <p:nvCxnSpPr>
-          <p:cNvPr id="852643260" name=""/>
+          <p:cNvPr id="2036762825" name=""/>
           <p:cNvCxnSpPr>
-            <a:stCxn id="1888988122" idx="0"/>
-            <a:endCxn id="2021581954" idx="1"/>
+            <a:stCxn id="290239998" idx="0"/>
+            <a:endCxn id="610845665" idx="1"/>
           </p:cNvCxnSpPr>
           <p:nvPr/>
         </p:nvCxnSpPr>
@@ -6889,10 +6889,10 @@
       </p:cxnSp>
       <p:cxnSp>
         <p:nvCxnSpPr>
-          <p:cNvPr id="563165706" name=""/>
+          <p:cNvPr id="112320479" name=""/>
           <p:cNvCxnSpPr>
-            <a:stCxn id="159929188" idx="0"/>
-            <a:endCxn id="2021581954" idx="3"/>
+            <a:stCxn id="635296686" idx="0"/>
+            <a:endCxn id="610845665" idx="3"/>
           </p:cNvCxnSpPr>
           <p:nvPr/>
         </p:nvCxnSpPr>
@@ -6936,10 +6936,10 @@
       </p:cxnSp>
       <p:cxnSp>
         <p:nvCxnSpPr>
-          <p:cNvPr id="1936786208" name=""/>
+          <p:cNvPr id="940014831" name=""/>
           <p:cNvCxnSpPr>
-            <a:stCxn id="1931292359" idx="0"/>
-            <a:endCxn id="2021581954" idx="2"/>
+            <a:stCxn id="290775617" idx="0"/>
+            <a:endCxn id="610845665" idx="2"/>
           </p:cNvCxnSpPr>
           <p:nvPr/>
         </p:nvCxnSpPr>
@@ -6983,7 +6983,7 @@
       </p:cxnSp>
       <p:sp>
         <p:nvSpPr>
-          <p:cNvPr id="982562846" name=""/>
+          <p:cNvPr id="1750220131" name=""/>
           <p:cNvSpPr/>
           <p:nvPr/>
         </p:nvSpPr>
@@ -7106,10 +7106,10 @@
       </p:sp>
       <p:cxnSp>
         <p:nvCxnSpPr>
-          <p:cNvPr id="1289290586" name=""/>
+          <p:cNvPr id="669542449" name=""/>
           <p:cNvCxnSpPr>
-            <a:stCxn id="159929188" idx="3"/>
-            <a:endCxn id="982562846" idx="1"/>
+            <a:stCxn id="635296686" idx="3"/>
+            <a:endCxn id="1750220131" idx="1"/>
           </p:cNvCxnSpPr>
           <p:nvPr/>
         </p:nvCxnSpPr>
@@ -7150,15 +7150,15 @@
       </p:cxnSp>
       <p:cxnSp>
         <p:nvCxnSpPr>
-          <p:cNvPr id="2069088655" name=""/>
+          <p:cNvPr id="1758027036" name=""/>
           <p:cNvCxnSpPr>
-            <a:stCxn id="159929188" idx="1"/>
-            <a:endCxn id="2128656028" idx="2"/>
+            <a:stCxn id="635296686" idx="1"/>
+            <a:endCxn id="1802444365" idx="2"/>
           </p:cNvCxnSpPr>
           <p:nvPr/>
         </p:nvCxnSpPr>
         <p:spPr bwMode="auto">
-          <a:xfrm rot="10799954" flipH="0" flipV="0">
+          <a:xfrm rot="10799953" flipH="0" flipV="0">
             <a:off x="2917629" y="4848025"/>
             <a:ext cx="2951312" cy="1048743"/>
           </a:xfrm>
@@ -7194,10 +7194,10 @@
       </p:cxnSp>
       <p:cxnSp>
         <p:nvCxnSpPr>
-          <p:cNvPr id="2038852732" name=""/>
+          <p:cNvPr id="1257555381" name=""/>
           <p:cNvCxnSpPr>
-            <a:stCxn id="1084796001" idx="3"/>
-            <a:endCxn id="159929188" idx="1"/>
+            <a:stCxn id="1069639831" idx="3"/>
+            <a:endCxn id="635296686" idx="1"/>
           </p:cNvCxnSpPr>
           <p:nvPr/>
         </p:nvCxnSpPr>
@@ -7238,10 +7238,10 @@
       </p:cxnSp>
       <p:cxnSp>
         <p:nvCxnSpPr>
-          <p:cNvPr id="425956064" name=""/>
+          <p:cNvPr id="488667655" name=""/>
           <p:cNvCxnSpPr>
-            <a:stCxn id="1888988122" idx="2"/>
-            <a:endCxn id="159929188" idx="1"/>
+            <a:stCxn id="290239998" idx="2"/>
+            <a:endCxn id="635296686" idx="1"/>
           </p:cNvCxnSpPr>
           <p:nvPr/>
         </p:nvCxnSpPr>
@@ -7282,15 +7282,15 @@
       </p:cxnSp>
       <p:cxnSp>
         <p:nvCxnSpPr>
-          <p:cNvPr id="525619050" name=""/>
+          <p:cNvPr id="2051338457" name=""/>
           <p:cNvCxnSpPr>
-            <a:stCxn id="982562846" idx="1"/>
-            <a:endCxn id="2021581954" idx="3"/>
+            <a:stCxn id="1750220131" idx="1"/>
+            <a:endCxn id="610845665" idx="3"/>
           </p:cNvCxnSpPr>
           <p:nvPr/>
         </p:nvCxnSpPr>
         <p:spPr bwMode="auto">
-          <a:xfrm rot="10799954" flipH="0" flipV="0">
+          <a:xfrm rot="10799953" flipH="0" flipV="0">
             <a:off x="5902238" y="2212816"/>
             <a:ext cx="2540720" cy="2041587"/>
           </a:xfrm>
@@ -7329,7 +7329,7 @@
       </p:cxnSp>
       <p:sp>
         <p:nvSpPr>
-          <p:cNvPr id="1025056842" name=""/>
+          <p:cNvPr id="1752639460" name=""/>
           <p:cNvSpPr txBox="1"/>
           <p:nvPr/>
         </p:nvSpPr>
@@ -7361,15 +7361,15 @@
       </p:sp>
       <p:cxnSp>
         <p:nvCxnSpPr>
-          <p:cNvPr id="1914021133" name=""/>
+          <p:cNvPr id="1075961317" name=""/>
           <p:cNvCxnSpPr>
-            <a:stCxn id="2021581954" idx="1"/>
-            <a:endCxn id="2128656028" idx="0"/>
+            <a:stCxn id="610845665" idx="1"/>
+            <a:endCxn id="1802444365" idx="0"/>
           </p:cNvCxnSpPr>
           <p:nvPr/>
         </p:nvCxnSpPr>
         <p:spPr bwMode="auto">
-          <a:xfrm rot="10799954" flipH="0" flipV="1">
+          <a:xfrm rot="10799953" flipH="0" flipV="1">
             <a:off x="2917629" y="2212816"/>
             <a:ext cx="1082376" cy="1638632"/>
           </a:xfrm>
@@ -7408,7 +7408,7 @@
       </p:cxnSp>
       <p:sp>
         <p:nvSpPr>
-          <p:cNvPr id="1408480899" name=""/>
+          <p:cNvPr id="790943239" name=""/>
           <p:cNvSpPr txBox="1"/>
           <p:nvPr/>
         </p:nvSpPr>
@@ -7440,7 +7440,7 @@
       </p:sp>
       <p:sp>
         <p:nvSpPr>
-          <p:cNvPr id="696007995" name=""/>
+          <p:cNvPr id="1633935433" name=""/>
           <p:cNvSpPr/>
           <p:nvPr/>
         </p:nvSpPr>
@@ -7607,7 +7607,7 @@
       </p:sp>
       <p:sp>
         <p:nvSpPr>
-          <p:cNvPr id="250599523" name=""/>
+          <p:cNvPr id="1875252943" name=""/>
           <p:cNvSpPr/>
           <p:nvPr/>
         </p:nvSpPr>
@@ -7774,10 +7774,10 @@
       </p:sp>
       <p:cxnSp>
         <p:nvCxnSpPr>
-          <p:cNvPr id="2045415339" name=""/>
+          <p:cNvPr id="237119424" name=""/>
           <p:cNvCxnSpPr>
-            <a:stCxn id="982562846" idx="3"/>
-            <a:endCxn id="250599523" idx="1"/>
+            <a:stCxn id="1750220131" idx="3"/>
+            <a:endCxn id="1875252943" idx="1"/>
           </p:cNvCxnSpPr>
           <p:nvPr/>
         </p:nvCxnSpPr>
@@ -7818,10 +7818,10 @@
       </p:cxnSp>
       <p:cxnSp>
         <p:nvCxnSpPr>
-          <p:cNvPr id="1168448175" name=""/>
+          <p:cNvPr id="817509843" name=""/>
           <p:cNvCxnSpPr>
-            <a:stCxn id="982562846" idx="3"/>
-            <a:endCxn id="696007995" idx="1"/>
+            <a:stCxn id="1750220131" idx="3"/>
+            <a:endCxn id="1633935433" idx="1"/>
           </p:cNvCxnSpPr>
           <p:nvPr/>
         </p:nvCxnSpPr>
@@ -7895,7 +7895,7 @@
       </p:grpSpPr>
       <p:sp>
         <p:nvSpPr>
-          <p:cNvPr id="1478918025" name=""/>
+          <p:cNvPr id="473679879" name=""/>
           <p:cNvSpPr/>
           <p:nvPr/>
         </p:nvSpPr>
@@ -7990,7 +7990,7 @@
       </p:sp>
       <p:sp>
         <p:nvSpPr>
-          <p:cNvPr id="226491601" name="Título 1"/>
+          <p:cNvPr id="2067614046" name="Título 1"/>
           <p:cNvSpPr>
             <a:spLocks noGrp="1"/>
           </p:cNvSpPr>
@@ -8036,7 +8036,7 @@
       </p:sp>
       <p:sp>
         <p:nvSpPr>
-          <p:cNvPr id="211951224" name=""/>
+          <p:cNvPr id="1546316079" name=""/>
           <p:cNvSpPr/>
           <p:nvPr/>
         </p:nvSpPr>
@@ -8145,7 +8145,7 @@
       </p:sp>
       <p:sp>
         <p:nvSpPr>
-          <p:cNvPr id="1779168902" name=""/>
+          <p:cNvPr id="528181993" name=""/>
           <p:cNvSpPr/>
           <p:nvPr/>
         </p:nvSpPr>
@@ -8424,7 +8424,7 @@
       </p:sp>
       <p:sp>
         <p:nvSpPr>
-          <p:cNvPr id="411018336" name=""/>
+          <p:cNvPr id="692926506" name=""/>
           <p:cNvSpPr/>
           <p:nvPr/>
         </p:nvSpPr>
@@ -8519,7 +8519,7 @@
       </p:sp>
       <p:sp>
         <p:nvSpPr>
-          <p:cNvPr id="1858074718" name=""/>
+          <p:cNvPr id="1539899421" name=""/>
           <p:cNvSpPr/>
           <p:nvPr/>
         </p:nvSpPr>
@@ -8714,10 +8714,10 @@
       </p:sp>
       <p:cxnSp>
         <p:nvCxnSpPr>
-          <p:cNvPr id="1867844537" name=""/>
+          <p:cNvPr id="1699948651" name=""/>
           <p:cNvCxnSpPr>
-            <a:stCxn id="211951224" idx="3"/>
-            <a:endCxn id="1779168902" idx="1"/>
+            <a:stCxn id="1546316079" idx="3"/>
+            <a:endCxn id="528181993" idx="1"/>
           </p:cNvCxnSpPr>
           <p:nvPr/>
         </p:nvCxnSpPr>
@@ -8761,10 +8761,10 @@
       </p:cxnSp>
       <p:cxnSp>
         <p:nvCxnSpPr>
-          <p:cNvPr id="840269748" name=""/>
+          <p:cNvPr id="1027301870" name=""/>
           <p:cNvCxnSpPr>
-            <a:stCxn id="1858074718" idx="0"/>
-            <a:endCxn id="1779168902" idx="3"/>
+            <a:stCxn id="1539899421" idx="0"/>
+            <a:endCxn id="528181993" idx="3"/>
           </p:cNvCxnSpPr>
           <p:nvPr/>
         </p:nvCxnSpPr>
@@ -8808,10 +8808,10 @@
       </p:cxnSp>
       <p:cxnSp>
         <p:nvCxnSpPr>
-          <p:cNvPr id="1251056429" name=""/>
+          <p:cNvPr id="1751573410" name=""/>
           <p:cNvCxnSpPr>
-            <a:stCxn id="1478918025" idx="0"/>
-            <a:endCxn id="1779168902" idx="2"/>
+            <a:stCxn id="473679879" idx="0"/>
+            <a:endCxn id="528181993" idx="2"/>
           </p:cNvCxnSpPr>
           <p:nvPr/>
         </p:nvCxnSpPr>
@@ -8855,7 +8855,7 @@
       </p:cxnSp>
       <p:sp>
         <p:nvSpPr>
-          <p:cNvPr id="998150284" name=""/>
+          <p:cNvPr id="764521061" name=""/>
           <p:cNvSpPr/>
           <p:nvPr/>
         </p:nvSpPr>
@@ -9022,10 +9022,10 @@
       </p:sp>
       <p:cxnSp>
         <p:nvCxnSpPr>
-          <p:cNvPr id="355135210" name=""/>
+          <p:cNvPr id="1428586097" name=""/>
           <p:cNvCxnSpPr>
-            <a:stCxn id="1858074718" idx="3"/>
-            <a:endCxn id="998150284" idx="1"/>
+            <a:stCxn id="1539899421" idx="3"/>
+            <a:endCxn id="764521061" idx="1"/>
           </p:cNvCxnSpPr>
           <p:nvPr/>
         </p:nvCxnSpPr>
@@ -9066,10 +9066,10 @@
       </p:cxnSp>
       <p:cxnSp>
         <p:nvCxnSpPr>
-          <p:cNvPr id="605449172" name=""/>
+          <p:cNvPr id="1767783755" name=""/>
           <p:cNvCxnSpPr>
-            <a:stCxn id="1858074718" idx="1"/>
-            <a:endCxn id="328520043" idx="3"/>
+            <a:stCxn id="1539899421" idx="1"/>
+            <a:endCxn id="507493943" idx="3"/>
           </p:cNvCxnSpPr>
           <p:nvPr/>
         </p:nvCxnSpPr>
@@ -9110,10 +9110,10 @@
       </p:cxnSp>
       <p:cxnSp>
         <p:nvCxnSpPr>
-          <p:cNvPr id="40959668" name=""/>
+          <p:cNvPr id="1529623956" name=""/>
           <p:cNvCxnSpPr>
-            <a:stCxn id="411018336" idx="3"/>
-            <a:endCxn id="1858074718" idx="1"/>
+            <a:stCxn id="692926506" idx="3"/>
+            <a:endCxn id="1539899421" idx="1"/>
           </p:cNvCxnSpPr>
           <p:nvPr/>
         </p:nvCxnSpPr>
@@ -9154,7 +9154,7 @@
       </p:cxnSp>
       <p:sp>
         <p:nvSpPr>
-          <p:cNvPr id="328520043" name=""/>
+          <p:cNvPr id="507493943" name=""/>
           <p:cNvSpPr/>
           <p:nvPr/>
         </p:nvSpPr>
@@ -9263,10 +9263,10 @@
       </p:sp>
       <p:cxnSp>
         <p:nvCxnSpPr>
-          <p:cNvPr id="1020827882" name=""/>
+          <p:cNvPr id="314239848" name=""/>
           <p:cNvCxnSpPr>
-            <a:stCxn id="211951224" idx="2"/>
-            <a:endCxn id="1858074718" idx="1"/>
+            <a:stCxn id="1546316079" idx="2"/>
+            <a:endCxn id="1539899421" idx="1"/>
           </p:cNvCxnSpPr>
           <p:nvPr/>
         </p:nvCxnSpPr>

</xml_diff>